<commit_message>
report & slides update
</commit_message>
<xml_diff>
--- a/report & slides/OCUSMAFAIT_presentation_Cloud.pptx
+++ b/report & slides/OCUSMAFAIT_presentation_Cloud.pptx
@@ -5158,7 +5158,7 @@
         </a:fontRef>
       </dsp:style>
       <dsp:txBody>
-        <a:bodyPr spcFirstLastPara="0" vert="horz" wrap="square" lIns="565775" tIns="50800" rIns="50800" bIns="50800" numCol="1" spcCol="1270" rtlCol="0" anchor="ctr" anchorCtr="0">
+        <a:bodyPr spcFirstLastPara="0" vert="horz" wrap="square" lIns="565775" tIns="50800" rIns="50800" bIns="50800" numCol="1" spcCol="1270" anchor="ctr" anchorCtr="0">
           <a:noAutofit/>
         </a:bodyPr>
         <a:lstStyle/>
@@ -23813,8 +23813,8 @@
         </p:nvSpPr>
         <p:spPr>
           <a:xfrm>
-            <a:off x="-457199" y="934588"/>
-            <a:ext cx="3964674" cy="1482582"/>
+            <a:off x="174170" y="976527"/>
+            <a:ext cx="3507475" cy="1482582"/>
           </a:xfrm>
         </p:spPr>
         <p:txBody>
@@ -24106,8 +24106,8 @@
         </p:nvSpPr>
         <p:spPr>
           <a:xfrm>
-            <a:off x="-1576316" y="6415156"/>
-            <a:ext cx="5602216" cy="307777"/>
+            <a:off x="232229" y="6400800"/>
+            <a:ext cx="3793670" cy="307777"/>
           </a:xfrm>
           <a:prstGeom prst="rect">
             <a:avLst/>

</xml_diff>